<commit_message>
Enforce canonical CeloHT terminology
</commit_message>
<xml_diff>
--- a/CeloHT-Investor-Deck.pptx
+++ b/CeloHT-Investor-Deck.pptx
@@ -4308,7 +4308,7 @@
                 <a:ea typeface="Georgia" pitchFamily="34" charset="-122"/>
                 <a:cs typeface="Georgia" pitchFamily="34" charset="-120"/>
               </a:rPr>
-              <a:t>cUSD</a:t>
+              <a:t>USDm</a:t>
             </a:r>
             <a:endParaRPr lang="en-US" sz="1500" dirty="0"/>
           </a:p>
@@ -5381,7 +5381,7 @@
                 <a:ea typeface="Georgia" pitchFamily="34" charset="-122"/>
                 <a:cs typeface="Georgia" pitchFamily="34" charset="-120"/>
               </a:rPr>
-              <a:t>Stable-value cUSD</a:t>
+              <a:t>Stable-value USDm</a:t>
             </a:r>
             <a:endParaRPr lang="en-US" sz="1600" dirty="0"/>
           </a:p>
@@ -16680,7 +16680,7 @@
                 <a:ea typeface="Calibri" pitchFamily="34" charset="-122"/>
                 <a:cs typeface="Calibri" pitchFamily="34" charset="-120"/>
               </a:rPr>
-              <a:t>github.com/Celo-HT</a:t>
+              <a:t>github.com/CeloHT</a:t>
             </a:r>
             <a:endParaRPr lang="en-US" sz="1400" dirty="0"/>
           </a:p>
@@ -18684,7 +18684,7 @@
                 <a:ea typeface="Calibri" pitchFamily="34" charset="-122"/>
                 <a:cs typeface="Calibri" pitchFamily="34" charset="-120"/>
               </a:rPr>
-              <a:t>Celo's design and cUSD's stability fit a population accessing finance primarily through a phone, not a bank branch.</a:t>
+              <a:t>Celo's design and USDm's stability fit a population accessing finance primarily through a phone, not a bank branch.</a:t>
             </a:r>
             <a:endParaRPr lang="en-US" sz="1250" dirty="0"/>
           </a:p>
@@ -19327,7 +19327,7 @@
                 <a:ea typeface="Calibri" pitchFamily="34" charset="-122"/>
                 <a:cs typeface="Calibri" pitchFamily="34" charset="-120"/>
               </a:rPr>
-              <a:t>A network of trained, on-chain-verified local agents who handle cash-to-cUSD conversion and answer questions an app alone never could.</a:t>
+              <a:t>A network of trained, on-chain-verified local agents who handle cash-to-USDm conversion and answer questions an app alone never could.</a:t>
             </a:r>
             <a:endParaRPr lang="en-US" sz="1250" dirty="0"/>
           </a:p>
@@ -20114,7 +20114,7 @@
                 <a:ea typeface="Calibri" pitchFamily="34" charset="-122"/>
                 <a:cs typeface="Calibri" pitchFamily="34" charset="-120"/>
               </a:rPr>
-              <a:t>Celo blockchain · cUSD (payments) · CELO (gas) · Valora (wallet)</a:t>
+              <a:t>Celo blockchain · USDm (payments) · CELO (gas) · Valora (wallet)</a:t>
             </a:r>
             <a:endParaRPr lang="en-US" sz="1250" dirty="0"/>
           </a:p>

</xml_diff>